<commit_message>
Azuriranje prezentacije i dokumentacije / Update presentation and documentation
</commit_message>
<xml_diff>
--- a/SmartAntenna Control/docs/SmartAntenna_Control_Prezentacija.pptx
+++ b/SmartAntenna Control/docs/SmartAntenna_Control_Prezentacija.pptx
@@ -3224,22 +3224,6 @@
             </a:r>
             <a:r>
               <a:rPr dirty="0" err="1"/>
-              <a:t>i</a:t>
-            </a:r>
-            <a:r>
-              <a:rPr dirty="0"/>
-              <a:t> </a:t>
-            </a:r>
-            <a:r>
-              <a:rPr dirty="0" err="1"/>
-              <a:t>noćno</a:t>
-            </a:r>
-            <a:r>
-              <a:rPr dirty="0"/>
-              <a:t> </a:t>
-            </a:r>
-            <a:r>
-              <a:rPr dirty="0" err="1"/>
               <a:t>upravljanje</a:t>
             </a:r>
             <a:r>

</xml_diff>